<commit_message>
Bella slide: cartoon Bella character, A4 PPTX and PDF
Co-Authored-By: Claude Opus 5.5 <noreply@anthropic.com>
Claude-Session: https://claude.ai/code/session_015ihzNHLGSNah22H2gkfaAe
</commit_message>
<xml_diff>
--- a/presentations/bella-setup-slide.pptx
+++ b/presentations/bella-setup-slide.pptx
@@ -10,8 +10,8 @@
   <p:notesMasterIdLst>
     <p:notesMasterId r:id="rId3"/>
   </p:notesMasterIdLst>
-  <p:sldSz cx="12192000" cy="6858000"/>
-  <p:notesSz cx="6858000" cy="12192000"/>
+  <p:sldSz cx="12191695" cy="6858000"/>
+  <p:notesSz cx="6858000" cy="12191695"/>
   <p:defaultTextStyle>
     <a:lvl1pPr marL="0" algn="l" defTabSz="914400" rtl="0" eaLnBrk="1" latinLnBrk="0" hangingPunct="1">
       <a:defRPr sz="1800" kern="1200">
@@ -107,7 +107,7 @@
   <p:extLst>
     <p:ext uri="{521415D9-36F7-43E2-AB2F-B90AF26B5E84}">
       <p14:sectionLst xmlns:p14="http://schemas.microsoft.com/office/powerpoint/2010/main">
-        <p14:section name="Onboarding" id="{12f37720-601f-dfe4-4c95-16e69d6cfe78}">
+        <p14:section name="Onboarding" id="{f9ada0f6-048e-3428-3ff9-f07c4e7f5bc8}">
           <p14:sldIdLst>
             <p14:sldId id="256"/>
           </p14:sldIdLst>
@@ -624,7 +624,7 @@
         <p:spPr>
           <a:xfrm>
             <a:off x="548640" y="411480"/>
-            <a:ext cx="11064240" cy="868680"/>
+            <a:ext cx="11094415" cy="868680"/>
           </a:xfrm>
           <a:prstGeom prst="rect">
             <a:avLst/>
@@ -980,7 +980,7 @@
         <p:spPr>
           <a:xfrm>
             <a:off x="548640" y="411480"/>
-            <a:ext cx="11064240" cy="868680"/>
+            <a:ext cx="11094415" cy="868680"/>
           </a:xfrm>
           <a:prstGeom prst="rect">
             <a:avLst/>
@@ -1019,7 +1019,7 @@
         <p:spPr>
           <a:xfrm>
             <a:off x="3429000" y="1554480"/>
-            <a:ext cx="0" cy="4526280"/>
+            <a:ext cx="0" cy="4572000"/>
           </a:xfrm>
           <a:prstGeom prst="line">
             <a:avLst/>
@@ -1041,8 +1041,8 @@
         </p:nvSpPr>
         <p:spPr>
           <a:xfrm>
-            <a:off x="8595360" y="1554480"/>
-            <a:ext cx="0" cy="4526280"/>
+            <a:off x="8598103" y="1554480"/>
+            <a:ext cx="0" cy="4572000"/>
           </a:xfrm>
           <a:prstGeom prst="line">
             <a:avLst/>
@@ -1064,8 +1064,8 @@
         </p:nvSpPr>
         <p:spPr>
           <a:xfrm>
-            <a:off x="548640" y="1463040"/>
-            <a:ext cx="914400" cy="868680"/>
+            <a:off x="548640" y="1508760"/>
+            <a:ext cx="914400" cy="777240"/>
           </a:xfrm>
           <a:prstGeom prst="rect">
             <a:avLst/>
@@ -1081,53 +1081,50 @@
               <a:buNone/>
             </a:pPr>
             <a:r>
-              <a:rPr lang="en-US" sz="6000" dirty="0">
+              <a:rPr lang="en-US" sz="5200" dirty="0">
                 <a:solidFill>
                   <a:schemeClr val="accent1"/>
+                </a:solidFill>
+              </a:rPr>
+              <a:t>1</a:t>
+            </a:r>
+            <a:endParaRPr lang="en-US" sz="5200" dirty="0"/>
+          </a:p>
+        </p:txBody>
+      </p:sp>
+      <p:sp>
+        <p:nvSpPr>
+          <p:cNvPr id="6" name="Step 1 heading"/>
+          <p:cNvSpPr txBox="1"/>
+          <p:nvPr/>
+        </p:nvSpPr>
+        <p:spPr>
+          <a:xfrm>
+            <a:off x="548640" y="2331720"/>
+            <a:ext cx="2651760" cy="777240"/>
+          </a:xfrm>
+          <a:prstGeom prst="rect">
+            <a:avLst/>
+          </a:prstGeom>
+          <a:noFill/>
+          <a:ln/>
+        </p:spPr>
+        <p:txBody>
+          <a:bodyPr wrap="square" lIns="0" tIns="0" rIns="0" bIns="0" rtlCol="0" anchor="t"/>
+          <a:lstStyle/>
+          <a:p>
+            <a:pPr indent="0" marL="0">
+              <a:buNone/>
+            </a:pPr>
+            <a:r>
+              <a:rPr lang="en-US" sz="2400" b="1" dirty="0">
+                <a:solidFill>
+                  <a:schemeClr val="bg1"/>
                 </a:solidFill>
                 <a:latin typeface="Cormorant Garamond" pitchFamily="34" charset="0"/>
                 <a:ea typeface="Cormorant Garamond" pitchFamily="34" charset="-122"/>
                 <a:cs typeface="Cormorant Garamond" pitchFamily="34" charset="-120"/>
               </a:rPr>
-              <a:t>1</a:t>
-            </a:r>
-            <a:endParaRPr lang="en-US" sz="6000" dirty="0"/>
-          </a:p>
-        </p:txBody>
-      </p:sp>
-      <p:sp>
-        <p:nvSpPr>
-          <p:cNvPr id="6" name="Step 1 heading"/>
-          <p:cNvSpPr txBox="1"/>
-          <p:nvPr/>
-        </p:nvSpPr>
-        <p:spPr>
-          <a:xfrm>
-            <a:off x="548640" y="2331720"/>
-            <a:ext cx="2651760" cy="777240"/>
-          </a:xfrm>
-          <a:prstGeom prst="rect">
-            <a:avLst/>
-          </a:prstGeom>
-          <a:noFill/>
-          <a:ln/>
-        </p:spPr>
-        <p:txBody>
-          <a:bodyPr wrap="square" lIns="0" tIns="0" rIns="0" bIns="0" rtlCol="0" anchor="t"/>
-          <a:lstStyle/>
-          <a:p>
-            <a:pPr indent="0" marL="0">
-              <a:buNone/>
-            </a:pPr>
-            <a:r>
-              <a:rPr lang="en-US" sz="2400" b="1" dirty="0">
-                <a:solidFill>
-                  <a:schemeClr val="bg1"/>
-                </a:solidFill>
-                <a:latin typeface="Cormorant Garamond" pitchFamily="34" charset="0"/>
-                <a:ea typeface="Cormorant Garamond" pitchFamily="34" charset="-122"/>
-                <a:cs typeface="Cormorant Garamond" pitchFamily="34" charset="-120"/>
-              </a:rPr>
               <a:t>Payment done</a:t>
             </a:r>
             <a:endParaRPr lang="en-US" sz="2400" dirty="0"/>
@@ -1142,7 +1139,7 @@
         </p:nvSpPr>
         <p:spPr>
           <a:xfrm>
-            <a:off x="548640" y="3154680"/>
+            <a:off x="548640" y="2971800"/>
             <a:ext cx="2651760" cy="548640"/>
           </a:xfrm>
           <a:prstGeom prst="rect">
@@ -1178,7 +1175,7 @@
         </p:nvSpPr>
         <p:spPr>
           <a:xfrm>
-            <a:off x="1005840" y="4023360"/>
+            <a:off x="1051560" y="4137660"/>
             <a:ext cx="1645920" cy="1645920"/>
           </a:xfrm>
           <a:prstGeom prst="ellipse">
@@ -1213,8 +1210,8 @@
         </p:blipFill>
         <p:spPr>
           <a:xfrm>
-            <a:off x="1371600" y="4389120"/>
-            <a:ext cx="914400" cy="914400"/>
+            <a:off x="1421892" y="4507992"/>
+            <a:ext cx="905256" cy="905256"/>
           </a:xfrm>
           <a:prstGeom prst="rect">
             <a:avLst/>
@@ -1229,8 +1226,8 @@
         </p:nvSpPr>
         <p:spPr>
           <a:xfrm>
-            <a:off x="3657600" y="1463040"/>
-            <a:ext cx="914400" cy="868680"/>
+            <a:off x="3657600" y="1508760"/>
+            <a:ext cx="914400" cy="777240"/>
           </a:xfrm>
           <a:prstGeom prst="rect">
             <a:avLst/>
@@ -1246,53 +1243,50 @@
               <a:buNone/>
             </a:pPr>
             <a:r>
-              <a:rPr lang="en-US" sz="6000" dirty="0">
+              <a:rPr lang="en-US" sz="5200" dirty="0">
                 <a:solidFill>
                   <a:schemeClr val="accent1"/>
+                </a:solidFill>
+              </a:rPr>
+              <a:t>2</a:t>
+            </a:r>
+            <a:endParaRPr lang="en-US" sz="5200" dirty="0"/>
+          </a:p>
+        </p:txBody>
+      </p:sp>
+      <p:sp>
+        <p:nvSpPr>
+          <p:cNvPr id="11" name="Step 2 heading"/>
+          <p:cNvSpPr txBox="1"/>
+          <p:nvPr/>
+        </p:nvSpPr>
+        <p:spPr>
+          <a:xfrm>
+            <a:off x="3657600" y="2331720"/>
+            <a:ext cx="4711903" cy="777240"/>
+          </a:xfrm>
+          <a:prstGeom prst="rect">
+            <a:avLst/>
+          </a:prstGeom>
+          <a:noFill/>
+          <a:ln/>
+        </p:spPr>
+        <p:txBody>
+          <a:bodyPr wrap="square" lIns="0" tIns="0" rIns="0" bIns="0" rtlCol="0" anchor="t"/>
+          <a:lstStyle/>
+          <a:p>
+            <a:pPr indent="0" marL="0">
+              <a:buNone/>
+            </a:pPr>
+            <a:r>
+              <a:rPr lang="en-US" sz="2400" b="1" dirty="0">
+                <a:solidFill>
+                  <a:schemeClr val="bg1"/>
                 </a:solidFill>
                 <a:latin typeface="Cormorant Garamond" pitchFamily="34" charset="0"/>
                 <a:ea typeface="Cormorant Garamond" pitchFamily="34" charset="-122"/>
                 <a:cs typeface="Cormorant Garamond" pitchFamily="34" charset="-120"/>
               </a:rPr>
-              <a:t>2</a:t>
-            </a:r>
-            <a:endParaRPr lang="en-US" sz="6000" dirty="0"/>
-          </a:p>
-        </p:txBody>
-      </p:sp>
-      <p:sp>
-        <p:nvSpPr>
-          <p:cNvPr id="11" name="Step 2 heading"/>
-          <p:cNvSpPr txBox="1"/>
-          <p:nvPr/>
-        </p:nvSpPr>
-        <p:spPr>
-          <a:xfrm>
-            <a:off x="3657600" y="2331720"/>
-            <a:ext cx="4709160" cy="777240"/>
-          </a:xfrm>
-          <a:prstGeom prst="rect">
-            <a:avLst/>
-          </a:prstGeom>
-          <a:noFill/>
-          <a:ln/>
-        </p:spPr>
-        <p:txBody>
-          <a:bodyPr wrap="square" lIns="0" tIns="0" rIns="0" bIns="0" rtlCol="0" anchor="t"/>
-          <a:lstStyle/>
-          <a:p>
-            <a:pPr indent="0" marL="0">
-              <a:buNone/>
-            </a:pPr>
-            <a:r>
-              <a:rPr lang="en-US" sz="2400" b="1" dirty="0">
-                <a:solidFill>
-                  <a:schemeClr val="bg1"/>
-                </a:solidFill>
-                <a:latin typeface="Cormorant Garamond" pitchFamily="34" charset="0"/>
-                <a:ea typeface="Cormorant Garamond" pitchFamily="34" charset="-122"/>
-                <a:cs typeface="Cormorant Garamond" pitchFamily="34" charset="-120"/>
-              </a:rPr>
               <a:t>Add Bella as co-host on Airbnb</a:t>
             </a:r>
             <a:endParaRPr lang="en-US" sz="2400" dirty="0"/>
@@ -1307,8 +1301,8 @@
         </p:nvSpPr>
         <p:spPr>
           <a:xfrm>
-            <a:off x="3657600" y="3154680"/>
-            <a:ext cx="4709160" cy="640080"/>
+            <a:off x="3657600" y="2971800"/>
+            <a:ext cx="4711903" cy="777240"/>
           </a:xfrm>
           <a:prstGeom prst="rect">
             <a:avLst/>
@@ -1418,7 +1412,7 @@
         </p:nvSpPr>
         <p:spPr>
           <a:xfrm>
-            <a:off x="4224528" y="3931920"/>
+            <a:off x="4251960" y="3931920"/>
             <a:ext cx="457200" cy="73152"/>
           </a:xfrm>
           <a:prstGeom prst="roundRect">
@@ -1864,7 +1858,7 @@
         <p:spPr>
           <a:xfrm>
             <a:off x="5733288" y="3840480"/>
-            <a:ext cx="2587752" cy="374904"/>
+            <a:ext cx="2590495" cy="374904"/>
           </a:xfrm>
           <a:prstGeom prst="rect">
             <a:avLst/>
@@ -1939,7 +1933,7 @@
         <p:spPr>
           <a:xfrm>
             <a:off x="5733288" y="4288536"/>
-            <a:ext cx="2587752" cy="374904"/>
+            <a:ext cx="2590495" cy="374904"/>
           </a:xfrm>
           <a:prstGeom prst="rect">
             <a:avLst/>
@@ -2047,7 +2041,7 @@
         <p:spPr>
           <a:xfrm>
             <a:off x="5733288" y="4736592"/>
-            <a:ext cx="2587752" cy="374904"/>
+            <a:ext cx="2590495" cy="374904"/>
           </a:xfrm>
           <a:prstGeom prst="rect">
             <a:avLst/>
@@ -2155,7 +2149,7 @@
         <p:spPr>
           <a:xfrm>
             <a:off x="5733288" y="5184648"/>
-            <a:ext cx="2587752" cy="374904"/>
+            <a:ext cx="2590495" cy="374904"/>
           </a:xfrm>
           <a:prstGeom prst="rect">
             <a:avLst/>
@@ -2224,7 +2218,7 @@
         <p:spPr>
           <a:xfrm>
             <a:off x="5413248" y="5614416"/>
-            <a:ext cx="2953512" cy="411480"/>
+            <a:ext cx="2956255" cy="411480"/>
           </a:xfrm>
           <a:prstGeom prst="roundRect">
             <a:avLst>
@@ -2285,7 +2279,7 @@
         <p:spPr>
           <a:xfrm>
             <a:off x="5733288" y="5632704"/>
-            <a:ext cx="2587752" cy="374904"/>
+            <a:ext cx="2590495" cy="374904"/>
           </a:xfrm>
           <a:prstGeom prst="rect">
             <a:avLst/>
@@ -2331,8 +2325,8 @@
         </p:nvSpPr>
         <p:spPr>
           <a:xfrm>
-            <a:off x="8823960" y="1463040"/>
-            <a:ext cx="914400" cy="868680"/>
+            <a:off x="8826703" y="1508760"/>
+            <a:ext cx="914400" cy="777240"/>
           </a:xfrm>
           <a:prstGeom prst="rect">
             <a:avLst/>
@@ -2348,53 +2342,50 @@
               <a:buNone/>
             </a:pPr>
             <a:r>
-              <a:rPr lang="en-US" sz="6000" dirty="0">
+              <a:rPr lang="en-US" sz="5200" dirty="0">
                 <a:solidFill>
                   <a:schemeClr val="accent1"/>
+                </a:solidFill>
+              </a:rPr>
+              <a:t>3</a:t>
+            </a:r>
+            <a:endParaRPr lang="en-US" sz="5200" dirty="0"/>
+          </a:p>
+        </p:txBody>
+      </p:sp>
+      <p:sp>
+        <p:nvSpPr>
+          <p:cNvPr id="40" name="Step 3 heading"/>
+          <p:cNvSpPr txBox="1"/>
+          <p:nvPr/>
+        </p:nvSpPr>
+        <p:spPr>
+          <a:xfrm>
+            <a:off x="8826703" y="2331720"/>
+            <a:ext cx="2816352" cy="777240"/>
+          </a:xfrm>
+          <a:prstGeom prst="rect">
+            <a:avLst/>
+          </a:prstGeom>
+          <a:noFill/>
+          <a:ln/>
+        </p:spPr>
+        <p:txBody>
+          <a:bodyPr wrap="square" lIns="0" tIns="0" rIns="0" bIns="0" rtlCol="0" anchor="t"/>
+          <a:lstStyle/>
+          <a:p>
+            <a:pPr indent="0" marL="0">
+              <a:buNone/>
+            </a:pPr>
+            <a:r>
+              <a:rPr lang="en-US" sz="2400" b="1" dirty="0">
+                <a:solidFill>
+                  <a:schemeClr val="bg1"/>
                 </a:solidFill>
                 <a:latin typeface="Cormorant Garamond" pitchFamily="34" charset="0"/>
                 <a:ea typeface="Cormorant Garamond" pitchFamily="34" charset="-122"/>
                 <a:cs typeface="Cormorant Garamond" pitchFamily="34" charset="-120"/>
               </a:rPr>
-              <a:t>3</a:t>
-            </a:r>
-            <a:endParaRPr lang="en-US" sz="6000" dirty="0"/>
-          </a:p>
-        </p:txBody>
-      </p:sp>
-      <p:sp>
-        <p:nvSpPr>
-          <p:cNvPr id="40" name="Step 3 heading"/>
-          <p:cNvSpPr txBox="1"/>
-          <p:nvPr/>
-        </p:nvSpPr>
-        <p:spPr>
-          <a:xfrm>
-            <a:off x="8823960" y="2331720"/>
-            <a:ext cx="2816352" cy="777240"/>
-          </a:xfrm>
-          <a:prstGeom prst="rect">
-            <a:avLst/>
-          </a:prstGeom>
-          <a:noFill/>
-          <a:ln/>
-        </p:spPr>
-        <p:txBody>
-          <a:bodyPr wrap="square" lIns="0" tIns="0" rIns="0" bIns="0" rtlCol="0" anchor="t"/>
-          <a:lstStyle/>
-          <a:p>
-            <a:pPr indent="0" marL="0">
-              <a:buNone/>
-            </a:pPr>
-            <a:r>
-              <a:rPr lang="en-US" sz="2400" b="1" dirty="0">
-                <a:solidFill>
-                  <a:schemeClr val="bg1"/>
-                </a:solidFill>
-                <a:latin typeface="Cormorant Garamond" pitchFamily="34" charset="0"/>
-                <a:ea typeface="Cormorant Garamond" pitchFamily="34" charset="-122"/>
-                <a:cs typeface="Cormorant Garamond" pitchFamily="34" charset="-120"/>
-              </a:rPr>
               <a:t>Done. You're now set.</a:t>
             </a:r>
             <a:endParaRPr lang="en-US" sz="2400" dirty="0"/>
@@ -2409,7 +2400,7 @@
         </p:nvSpPr>
         <p:spPr>
           <a:xfrm>
-            <a:off x="8823960" y="3154680"/>
+            <a:off x="8826703" y="2971800"/>
             <a:ext cx="2816352" cy="868680"/>
           </a:xfrm>
           <a:prstGeom prst="rect">
@@ -2436,35 +2427,10 @@
             <a:endParaRPr lang="en-US" sz="1400" dirty="0"/>
           </a:p>
         </p:txBody>
-      </p:sp>
-      <p:sp>
-        <p:nvSpPr>
-          <p:cNvPr id="42" name="Bella frame"/>
-          <p:cNvSpPr/>
-          <p:nvPr/>
-        </p:nvSpPr>
-        <p:spPr>
-          <a:xfrm>
-            <a:off x="9281160" y="4206240"/>
-            <a:ext cx="1554480" cy="1554480"/>
-          </a:xfrm>
-          <a:prstGeom prst="ellipse">
-            <a:avLst/>
-          </a:prstGeom>
-          <a:solidFill>
-            <a:schemeClr val="tx2"/>
-          </a:solidFill>
-          <a:ln w="15875">
-            <a:solidFill>
-              <a:schemeClr val="accent1"/>
-            </a:solidFill>
-            <a:prstDash val="solid"/>
-          </a:ln>
-        </p:spPr>
       </p:sp>
       <p:pic>
         <p:nvPicPr>
-          <p:cNvPr id="43" name="Bella character placeholder (replace with art)" descr="preencoded.png">    </p:cNvPr>
+          <p:cNvPr id="42" name="Bella character" descr="Bella, the Red Flag Homes host assistant, waving">    </p:cNvPr>
           <p:cNvPicPr>
             <a:picLocks noChangeAspect="1"/>
           </p:cNvPicPr>
@@ -2478,17 +2444,56 @@
         </p:blipFill>
         <p:spPr>
           <a:xfrm>
-            <a:off x="9509760" y="4434840"/>
-            <a:ext cx="1097280" cy="1143000"/>
+            <a:off x="9145029" y="3749040"/>
+            <a:ext cx="2362581" cy="2423160"/>
           </a:xfrm>
           <a:prstGeom prst="rect">
             <a:avLst/>
           </a:prstGeom>
         </p:spPr>
       </p:pic>
+      <p:sp>
+        <p:nvSpPr>
+          <p:cNvPr id="43" name="Full access line"/>
+          <p:cNvSpPr txBox="1"/>
+          <p:nvPr/>
+        </p:nvSpPr>
+        <p:spPr>
+          <a:xfrm>
+            <a:off x="548640" y="6263640"/>
+            <a:ext cx="5486400" cy="365760"/>
+          </a:xfrm>
+          <a:prstGeom prst="rect">
+            <a:avLst/>
+          </a:prstGeom>
+          <a:noFill/>
+          <a:ln/>
+        </p:spPr>
+        <p:txBody>
+          <a:bodyPr wrap="square" lIns="0" tIns="0" rIns="0" bIns="0" rtlCol="0" anchor="ctr"/>
+          <a:lstStyle/>
+          <a:p>
+            <a:pPr indent="0" marL="0">
+              <a:buNone/>
+            </a:pPr>
+            <a:r>
+              <a:rPr lang="en-US" sz="1800" i="1" dirty="0">
+                <a:solidFill>
+                  <a:schemeClr val="accent1"/>
+                </a:solidFill>
+                <a:latin typeface="Cormorant Garamond" pitchFamily="34" charset="0"/>
+                <a:ea typeface="Cormorant Garamond" pitchFamily="34" charset="-122"/>
+                <a:cs typeface="Cormorant Garamond" pitchFamily="34" charset="-120"/>
+              </a:rPr>
+              <a:t>Full access lets Bella do everything for you.</a:t>
+            </a:r>
+            <a:endParaRPr lang="en-US" sz="1800" dirty="0"/>
+          </a:p>
+        </p:txBody>
+      </p:sp>
       <p:pic>
         <p:nvPicPr>
-          <p:cNvPr id="44" name="Bella wave" descr="preencoded.png">    </p:cNvPr>
+          <p:cNvPr id="44" name="WhatsApp icon" descr="preencoded.png">    </p:cNvPr>
           <p:cNvPicPr>
             <a:picLocks noChangeAspect="1"/>
           </p:cNvPicPr>
@@ -2502,8 +2507,8 @@
         </p:blipFill>
         <p:spPr>
           <a:xfrm>
-            <a:off x="10515600" y="4069080"/>
-            <a:ext cx="502920" cy="502920"/>
+            <a:off x="8616391" y="6318504"/>
+            <a:ext cx="256032" cy="256032"/>
           </a:xfrm>
           <a:prstGeom prst="rect">
             <a:avLst/>
@@ -2512,77 +2517,14 @@
       </p:pic>
       <p:sp>
         <p:nvSpPr>
-          <p:cNvPr id="45" name="Full access line"/>
+          <p:cNvPr id="45" name="Help line"/>
           <p:cNvSpPr txBox="1"/>
           <p:nvPr/>
         </p:nvSpPr>
         <p:spPr>
           <a:xfrm>
-            <a:off x="548640" y="6263640"/>
-            <a:ext cx="5943600" cy="365760"/>
-          </a:xfrm>
-          <a:prstGeom prst="rect">
-            <a:avLst/>
-          </a:prstGeom>
-          <a:noFill/>
-          <a:ln/>
-        </p:spPr>
-        <p:txBody>
-          <a:bodyPr wrap="square" lIns="0" tIns="0" rIns="0" bIns="0" rtlCol="0" anchor="ctr"/>
-          <a:lstStyle/>
-          <a:p>
-            <a:pPr indent="0" marL="0">
-              <a:buNone/>
-            </a:pPr>
-            <a:r>
-              <a:rPr lang="en-US" sz="1800" i="1" dirty="0">
-                <a:solidFill>
-                  <a:schemeClr val="accent1"/>
-                </a:solidFill>
-                <a:latin typeface="Cormorant Garamond" pitchFamily="34" charset="0"/>
-                <a:ea typeface="Cormorant Garamond" pitchFamily="34" charset="-122"/>
-                <a:cs typeface="Cormorant Garamond" pitchFamily="34" charset="-120"/>
-              </a:rPr>
-              <a:t>Full access lets Bella do everything for you.</a:t>
-            </a:r>
-            <a:endParaRPr lang="en-US" sz="1800" dirty="0"/>
-          </a:p>
-        </p:txBody>
-      </p:sp>
-      <p:pic>
-        <p:nvPicPr>
-          <p:cNvPr id="46" name="WhatsApp icon" descr="preencoded.png">    </p:cNvPr>
-          <p:cNvPicPr>
-            <a:picLocks noChangeAspect="1"/>
-          </p:cNvPicPr>
-          <p:nvPr/>
-        </p:nvPicPr>
-        <p:blipFill>
-          <a:blip r:embed="rId5"/>
-          <a:stretch>
-            <a:fillRect/>
-          </a:stretch>
-        </p:blipFill>
-        <p:spPr>
-          <a:xfrm>
-            <a:off x="8595360" y="6318504"/>
-            <a:ext cx="256032" cy="256032"/>
-          </a:xfrm>
-          <a:prstGeom prst="rect">
-            <a:avLst/>
-          </a:prstGeom>
-        </p:spPr>
-      </p:pic>
-      <p:sp>
-        <p:nvSpPr>
-          <p:cNvPr id="47" name="Help line"/>
-          <p:cNvSpPr txBox="1"/>
-          <p:nvPr/>
-        </p:nvSpPr>
-        <p:spPr>
-          <a:xfrm>
-            <a:off x="8924544" y="6263640"/>
-            <a:ext cx="2743200" cy="365760"/>
+            <a:off x="8945575" y="6263640"/>
+            <a:ext cx="2697480" cy="365760"/>
           </a:xfrm>
           <a:prstGeom prst="rect">
             <a:avLst/>

</xml_diff>